<commit_message>
deck: fold LLM-as-judge trade-off + TRADEOFFS.md pointer into the trade-offs slide
Slide 9 (Decisions & trade-offs) is now an 8-cell 4×2 grid: 7 trade-off cards —
added "LLM-as-judge (RSI critic)" (vs an ADK/ReAct critic: a single structured
call, no tool loop) alongside the deterministic gate, agent-as-tool, deterministic
pre-processing, native function-calling, one-Gemini-model, and graceful-fallback —
plus an 8th violet pointer card to TRADEOFFS.md (every decision: options → chosen →
why). Whys tightened to fit; speaker notes updated.

Rendered + visually verified via PowerPoint; geometry lint clean; 18 slides.
Deck only — no app change.

Co-Authored-By: Claude Opus 4.8 <noreply@anthropic.com>
</commit_message>
<xml_diff>
--- a/PRESENTATION.pptx
+++ b/PRESENTATION.pptx
@@ -2015,7 +2015,7 @@
           <a:p>
             <a:r>
               <a:rPr lang="en-US" dirty="0"/>
-              <a:t>Defend the design (3 min — the technical-acumen score). For each: name the choice, the alternative, and WHY. The headline trade-off is the deterministic gate — we deliberately keep the LLM OUT of executing payments. Agent-as-tool prevents loops structurally. We didn't force deterministic work into agents. We use native function-calling for reliability and reserve explicit ReAct for the one read-only advisor. One Gemini model on Vertex keeps ops and latency down. And graceful fallback + self-healing means we degrade, not fail. Invite the expert to push on any row — this is where the conversation gets good.</a:t>
+              <a:t>Defend the design (3 min — the technical-acumen score). For each: name the choice, the alternative, and WHY. Headline: the deterministic gate keeps the LLM OUT of executing payments. Agent-as-tool prevents loops structurally. We didn't force deterministic work into agents. Native function-calling for reliability; explicit ReAct only for the read-only advisor. The RSI critic is an LLM-as-judge — a single structured call, NOT an ADK/ReAct agent — because judging a failure has no multi-step tool loop. One Gemini model on Vertex; graceful fallback + self-heal so we degrade, not fail. The full log of every trade-off (options → chosen → why) is in TRADEOFFS.md — invite the expert to push on any row.</a:t>
             </a:r>
             <a:endParaRPr lang="en-US" dirty="0"/>
           </a:p>
@@ -31682,12 +31682,12 @@
         </p:nvSpPr>
         <p:spPr>
           <a:xfrm>
-            <a:off x="502920" y="1737360"/>
-            <a:ext cx="5364328" cy="1280160"/>
+            <a:off x="502920" y="1664208"/>
+            <a:ext cx="5364328" cy="1078992"/>
           </a:xfrm>
           <a:prstGeom prst="roundRect">
             <a:avLst>
-              <a:gd name="adj" fmla="val 5714"/>
+              <a:gd name="adj" fmla="val 6780"/>
             </a:avLst>
           </a:prstGeom>
           <a:solidFill>
@@ -31716,12 +31716,12 @@
         </p:nvSpPr>
         <p:spPr>
           <a:xfrm>
-            <a:off x="685800" y="1938528"/>
-            <a:ext cx="457200" cy="457200"/>
+            <a:off x="685800" y="1847088"/>
+            <a:ext cx="420624" cy="420624"/>
           </a:xfrm>
           <a:prstGeom prst="roundRect">
             <a:avLst>
-              <a:gd name="adj" fmla="val 20000"/>
+              <a:gd name="adj" fmla="val 21739"/>
             </a:avLst>
           </a:prstGeom>
           <a:solidFill>
@@ -31746,8 +31746,8 @@
         </p:blipFill>
         <p:spPr>
           <a:xfrm>
-            <a:off x="795528" y="2048256"/>
-            <a:ext cx="237744" cy="237744"/>
+            <a:off x="786384" y="1947672"/>
+            <a:ext cx="219456" cy="219456"/>
           </a:xfrm>
           <a:prstGeom prst="rect">
             <a:avLst/>
@@ -31762,8 +31762,8 @@
         </p:nvSpPr>
         <p:spPr>
           <a:xfrm>
-            <a:off x="1252728" y="1883664"/>
-            <a:ext cx="4449928" cy="310896"/>
+            <a:off x="1216152" y="1792224"/>
+            <a:ext cx="4486504" cy="274320"/>
           </a:xfrm>
           <a:prstGeom prst="rect">
             <a:avLst/>
@@ -31779,7 +31779,7 @@
               <a:buNone/>
             </a:pPr>
             <a:r>
-              <a:rPr lang="en-US" sz="1350" b="1" dirty="0">
+              <a:rPr lang="en-US" sz="1300" b="1" dirty="0">
                 <a:solidFill>
                   <a:srgbClr val="0F172A"/>
                 </a:solidFill>
@@ -31789,7 +31789,7 @@
               </a:rPr>
               <a:t>Deterministic transactional gate</a:t>
             </a:r>
-            <a:endParaRPr lang="en-US" sz="1350" dirty="0"/>
+            <a:endParaRPr lang="en-US" sz="1300" dirty="0"/>
           </a:p>
         </p:txBody>
       </p:sp>
@@ -31801,8 +31801,8 @@
         </p:nvSpPr>
         <p:spPr>
           <a:xfrm>
-            <a:off x="1252728" y="2167128"/>
-            <a:ext cx="4449928" cy="237744"/>
+            <a:off x="1216152" y="2066544"/>
+            <a:ext cx="4486504" cy="219456"/>
           </a:xfrm>
           <a:prstGeom prst="rect">
             <a:avLst/>
@@ -31818,7 +31818,7 @@
               <a:buNone/>
             </a:pPr>
             <a:r>
-              <a:rPr lang="en-US" sz="1050" i="1" dirty="0">
+              <a:rPr lang="en-US" sz="1000" i="1" dirty="0">
                 <a:solidFill>
                   <a:srgbClr val="E11D48"/>
                 </a:solidFill>
@@ -31826,13 +31826,13 @@
                 <a:ea typeface="Calibri" pitchFamily="34" charset="-122"/>
                 <a:cs typeface="Calibri" pitchFamily="34" charset="-120"/>
               </a:rPr>
-              <a:t>Chosen over: </a:t>
+              <a:t>vs </a:t>
             </a:r>
             <a:pPr indent="0" marL="0">
               <a:buNone/>
             </a:pPr>
             <a:r>
-              <a:rPr lang="en-US" sz="1050" i="1" dirty="0">
+              <a:rPr lang="en-US" sz="1000" i="1" dirty="0">
                 <a:solidFill>
                   <a:srgbClr val="8A94A6"/>
                 </a:solidFill>
@@ -31840,9 +31840,9 @@
                 <a:ea typeface="Calibri" pitchFamily="34" charset="-122"/>
                 <a:cs typeface="Calibri" pitchFamily="34" charset="-120"/>
               </a:rPr>
-              <a:t>LLM places orders end-to-end</a:t>
-            </a:r>
-            <a:endParaRPr lang="en-US" sz="1050" dirty="0"/>
+              <a:t>the LLM places orders</a:t>
+            </a:r>
+            <a:endParaRPr lang="en-US" sz="1000" dirty="0"/>
           </a:p>
         </p:txBody>
       </p:sp>
@@ -31854,8 +31854,8 @@
         </p:nvSpPr>
         <p:spPr>
           <a:xfrm>
-            <a:off x="704088" y="2450592"/>
-            <a:ext cx="4980280" cy="512064"/>
+            <a:off x="704088" y="2322576"/>
+            <a:ext cx="4980280" cy="384048"/>
           </a:xfrm>
           <a:prstGeom prst="rect">
             <a:avLst/>
@@ -31871,7 +31871,7 @@
               <a:buNone/>
             </a:pPr>
             <a:r>
-              <a:rPr lang="en-US" sz="1100" dirty="0">
+              <a:rPr lang="en-US" sz="1050" dirty="0">
                 <a:solidFill>
                   <a:srgbClr val="5B6577"/>
                 </a:solidFill>
@@ -31879,9 +31879,9 @@
                 <a:ea typeface="Calibri" pitchFamily="34" charset="-122"/>
                 <a:cs typeface="Calibri" pitchFamily="34" charset="-120"/>
               </a:rPr>
-              <a:t>“LLM orchestrates, code transacts.” Money/inventory actions are structured, auditable, reproducible — never a hallucinated purchase.</a:t>
-            </a:r>
-            <a:endParaRPr lang="en-US" sz="1100" dirty="0"/>
+              <a:t>Money/inventory = auditable code, never a hallucinated purchase.</a:t>
+            </a:r>
+            <a:endParaRPr lang="en-US" sz="1050" dirty="0"/>
           </a:p>
         </p:txBody>
       </p:sp>
@@ -31893,12 +31893,12 @@
         </p:nvSpPr>
         <p:spPr>
           <a:xfrm>
-            <a:off x="6324448" y="1737360"/>
-            <a:ext cx="5364328" cy="1280160"/>
+            <a:off x="6324448" y="1664208"/>
+            <a:ext cx="5364328" cy="1078992"/>
           </a:xfrm>
           <a:prstGeom prst="roundRect">
             <a:avLst>
-              <a:gd name="adj" fmla="val 5714"/>
+              <a:gd name="adj" fmla="val 6780"/>
             </a:avLst>
           </a:prstGeom>
           <a:solidFill>
@@ -31927,12 +31927,12 @@
         </p:nvSpPr>
         <p:spPr>
           <a:xfrm>
-            <a:off x="6507328" y="1938528"/>
-            <a:ext cx="457200" cy="457200"/>
+            <a:off x="6507328" y="1847088"/>
+            <a:ext cx="420624" cy="420624"/>
           </a:xfrm>
           <a:prstGeom prst="roundRect">
             <a:avLst>
-              <a:gd name="adj" fmla="val 20000"/>
+              <a:gd name="adj" fmla="val 21739"/>
             </a:avLst>
           </a:prstGeom>
           <a:solidFill>
@@ -31957,8 +31957,8 @@
         </p:blipFill>
         <p:spPr>
           <a:xfrm>
-            <a:off x="6617056" y="2048256"/>
-            <a:ext cx="237744" cy="237744"/>
+            <a:off x="6607912" y="1947672"/>
+            <a:ext cx="219456" cy="219456"/>
           </a:xfrm>
           <a:prstGeom prst="rect">
             <a:avLst/>
@@ -31973,8 +31973,8 @@
         </p:nvSpPr>
         <p:spPr>
           <a:xfrm>
-            <a:off x="7074256" y="1883664"/>
-            <a:ext cx="4449928" cy="310896"/>
+            <a:off x="7037680" y="1792224"/>
+            <a:ext cx="4486504" cy="274320"/>
           </a:xfrm>
           <a:prstGeom prst="rect">
             <a:avLst/>
@@ -31990,7 +31990,7 @@
               <a:buNone/>
             </a:pPr>
             <a:r>
-              <a:rPr lang="en-US" sz="1350" b="1" dirty="0">
+              <a:rPr lang="en-US" sz="1300" b="1" dirty="0">
                 <a:solidFill>
                   <a:srgbClr val="0F172A"/>
                 </a:solidFill>
@@ -32000,7 +32000,7 @@
               </a:rPr>
               <a:t>Agent-as-tool (not transfer)</a:t>
             </a:r>
-            <a:endParaRPr lang="en-US" sz="1350" dirty="0"/>
+            <a:endParaRPr lang="en-US" sz="1300" dirty="0"/>
           </a:p>
         </p:txBody>
       </p:sp>
@@ -32012,8 +32012,8 @@
         </p:nvSpPr>
         <p:spPr>
           <a:xfrm>
-            <a:off x="7074256" y="2167128"/>
-            <a:ext cx="4449928" cy="237744"/>
+            <a:off x="7037680" y="2066544"/>
+            <a:ext cx="4486504" cy="219456"/>
           </a:xfrm>
           <a:prstGeom prst="rect">
             <a:avLst/>
@@ -32029,7 +32029,7 @@
               <a:buNone/>
             </a:pPr>
             <a:r>
-              <a:rPr lang="en-US" sz="1050" i="1" dirty="0">
+              <a:rPr lang="en-US" sz="1000" i="1" dirty="0">
                 <a:solidFill>
                   <a:srgbClr val="E11D48"/>
                 </a:solidFill>
@@ -32037,13 +32037,13 @@
                 <a:ea typeface="Calibri" pitchFamily="34" charset="-122"/>
                 <a:cs typeface="Calibri" pitchFamily="34" charset="-120"/>
               </a:rPr>
-              <a:t>Chosen over: </a:t>
+              <a:t>vs </a:t>
             </a:r>
             <a:pPr indent="0" marL="0">
               <a:buNone/>
             </a:pPr>
             <a:r>
-              <a:rPr lang="en-US" sz="1050" i="1" dirty="0">
+              <a:rPr lang="en-US" sz="1000" i="1" dirty="0">
                 <a:solidFill>
                   <a:srgbClr val="8A94A6"/>
                 </a:solidFill>
@@ -32051,9 +32051,9 @@
                 <a:ea typeface="Calibri" pitchFamily="34" charset="-122"/>
                 <a:cs typeface="Calibri" pitchFamily="34" charset="-120"/>
               </a:rPr>
-              <a:t>sub_agents / transfer handoff</a:t>
-            </a:r>
-            <a:endParaRPr lang="en-US" sz="1050" dirty="0"/>
+              <a:t>sub_agents / transfer</a:t>
+            </a:r>
+            <a:endParaRPr lang="en-US" sz="1000" dirty="0"/>
           </a:p>
         </p:txBody>
       </p:sp>
@@ -32065,8 +32065,8 @@
         </p:nvSpPr>
         <p:spPr>
           <a:xfrm>
-            <a:off x="6525616" y="2450592"/>
-            <a:ext cx="4980280" cy="512064"/>
+            <a:off x="6525616" y="2322576"/>
+            <a:ext cx="4980280" cy="384048"/>
           </a:xfrm>
           <a:prstGeom prst="rect">
             <a:avLst/>
@@ -32082,7 +32082,7 @@
               <a:buNone/>
             </a:pPr>
             <a:r>
-              <a:rPr lang="en-US" sz="1100" dirty="0">
+              <a:rPr lang="en-US" sz="1050" dirty="0">
                 <a:solidFill>
                   <a:srgbClr val="5B6577"/>
                 </a:solidFill>
@@ -32090,9 +32090,9 @@
                 <a:ea typeface="Calibri" pitchFamily="34" charset="-122"/>
                 <a:cs typeface="Calibri" pitchFamily="34" charset="-120"/>
               </a:rPr>
-              <a:t>Orchestrator stays in control &amp; composes the reply; workers can't transfer back → delegation loops are impossible by construction.</a:t>
-            </a:r>
-            <a:endParaRPr lang="en-US" sz="1100" dirty="0"/>
+              <a:t>Workers can't hand control back → delegation loops can't form.</a:t>
+            </a:r>
+            <a:endParaRPr lang="en-US" sz="1050" dirty="0"/>
           </a:p>
         </p:txBody>
       </p:sp>
@@ -32104,12 +32104,12 @@
         </p:nvSpPr>
         <p:spPr>
           <a:xfrm>
-            <a:off x="502920" y="3182112"/>
-            <a:ext cx="5364328" cy="1280160"/>
+            <a:off x="502920" y="2871216"/>
+            <a:ext cx="5364328" cy="1078992"/>
           </a:xfrm>
           <a:prstGeom prst="roundRect">
             <a:avLst>
-              <a:gd name="adj" fmla="val 5714"/>
+              <a:gd name="adj" fmla="val 6780"/>
             </a:avLst>
           </a:prstGeom>
           <a:solidFill>
@@ -32138,12 +32138,12 @@
         </p:nvSpPr>
         <p:spPr>
           <a:xfrm>
-            <a:off x="685800" y="3383280"/>
-            <a:ext cx="457200" cy="457200"/>
+            <a:off x="685800" y="3054096"/>
+            <a:ext cx="420624" cy="420624"/>
           </a:xfrm>
           <a:prstGeom prst="roundRect">
             <a:avLst>
-              <a:gd name="adj" fmla="val 20000"/>
+              <a:gd name="adj" fmla="val 21739"/>
             </a:avLst>
           </a:prstGeom>
           <a:solidFill>
@@ -32168,8 +32168,8 @@
         </p:blipFill>
         <p:spPr>
           <a:xfrm>
-            <a:off x="795528" y="3493008"/>
-            <a:ext cx="237744" cy="237744"/>
+            <a:off x="786384" y="3154680"/>
+            <a:ext cx="219456" cy="219456"/>
           </a:xfrm>
           <a:prstGeom prst="rect">
             <a:avLst/>
@@ -32184,8 +32184,8 @@
         </p:nvSpPr>
         <p:spPr>
           <a:xfrm>
-            <a:off x="1252728" y="3328416"/>
-            <a:ext cx="4449928" cy="310896"/>
+            <a:off x="1216152" y="2999232"/>
+            <a:ext cx="4486504" cy="274320"/>
           </a:xfrm>
           <a:prstGeom prst="rect">
             <a:avLst/>
@@ -32201,7 +32201,7 @@
               <a:buNone/>
             </a:pPr>
             <a:r>
-              <a:rPr lang="en-US" sz="1350" b="1" dirty="0">
+              <a:rPr lang="en-US" sz="1300" b="1" dirty="0">
                 <a:solidFill>
                   <a:srgbClr val="0F172A"/>
                 </a:solidFill>
@@ -32211,7 +32211,7 @@
               </a:rPr>
               <a:t>Deterministic pre-processing</a:t>
             </a:r>
-            <a:endParaRPr lang="en-US" sz="1350" dirty="0"/>
+            <a:endParaRPr lang="en-US" sz="1300" dirty="0"/>
           </a:p>
         </p:txBody>
       </p:sp>
@@ -32223,8 +32223,8 @@
         </p:nvSpPr>
         <p:spPr>
           <a:xfrm>
-            <a:off x="1252728" y="3611880"/>
-            <a:ext cx="4449928" cy="237744"/>
+            <a:off x="1216152" y="3273552"/>
+            <a:ext cx="4486504" cy="219456"/>
           </a:xfrm>
           <a:prstGeom prst="rect">
             <a:avLst/>
@@ -32240,7 +32240,7 @@
               <a:buNone/>
             </a:pPr>
             <a:r>
-              <a:rPr lang="en-US" sz="1050" i="1" dirty="0">
+              <a:rPr lang="en-US" sz="1000" i="1" dirty="0">
                 <a:solidFill>
                   <a:srgbClr val="E11D48"/>
                 </a:solidFill>
@@ -32248,13 +32248,13 @@
                 <a:ea typeface="Calibri" pitchFamily="34" charset="-122"/>
                 <a:cs typeface="Calibri" pitchFamily="34" charset="-120"/>
               </a:rPr>
-              <a:t>Chosen over: </a:t>
+              <a:t>vs </a:t>
             </a:r>
             <a:pPr indent="0" marL="0">
               <a:buNone/>
             </a:pPr>
             <a:r>
-              <a:rPr lang="en-US" sz="1050" i="1" dirty="0">
+              <a:rPr lang="en-US" sz="1000" i="1" dirty="0">
                 <a:solidFill>
                   <a:srgbClr val="8A94A6"/>
                 </a:solidFill>
@@ -32262,9 +32262,9 @@
                 <a:ea typeface="Calibri" pitchFamily="34" charset="-122"/>
                 <a:cs typeface="Calibri" pitchFamily="34" charset="-120"/>
               </a:rPr>
-              <a:t>modality/lang/channel as LLM agents</a:t>
-            </a:r>
-            <a:endParaRPr lang="en-US" sz="1050" dirty="0"/>
+              <a:t>modality/lang as LLM agents</a:t>
+            </a:r>
+            <a:endParaRPr lang="en-US" sz="1000" dirty="0"/>
           </a:p>
         </p:txBody>
       </p:sp>
@@ -32276,8 +32276,8 @@
         </p:nvSpPr>
         <p:spPr>
           <a:xfrm>
-            <a:off x="704088" y="3895344"/>
-            <a:ext cx="4980280" cy="512064"/>
+            <a:off x="704088" y="3529584"/>
+            <a:ext cx="4980280" cy="384048"/>
           </a:xfrm>
           <a:prstGeom prst="rect">
             <a:avLst/>
@@ -32293,7 +32293,7 @@
               <a:buNone/>
             </a:pPr>
             <a:r>
-              <a:rPr lang="en-US" sz="1100" dirty="0">
+              <a:rPr lang="en-US" sz="1050" dirty="0">
                 <a:solidFill>
                   <a:srgbClr val="5B6577"/>
                 </a:solidFill>
@@ -32301,9 +32301,9 @@
                 <a:ea typeface="Calibri" pitchFamily="34" charset="-122"/>
                 <a:cs typeface="Calibri" pitchFamily="34" charset="-120"/>
               </a:rPr>
-              <a:t>We tried LLM agents — they failed for zero benefit. Detecting language needs no intelligence; plain code is reliable &amp; free.</a:t>
-            </a:r>
-            <a:endParaRPr lang="en-US" sz="1100" dirty="0"/>
+              <a:t>No intelligence needed → plain code is reliable &amp; free.</a:t>
+            </a:r>
+            <a:endParaRPr lang="en-US" sz="1050" dirty="0"/>
           </a:p>
         </p:txBody>
       </p:sp>
@@ -32315,12 +32315,12 @@
         </p:nvSpPr>
         <p:spPr>
           <a:xfrm>
-            <a:off x="6324448" y="3182112"/>
-            <a:ext cx="5364328" cy="1280160"/>
+            <a:off x="6324448" y="2871216"/>
+            <a:ext cx="5364328" cy="1078992"/>
           </a:xfrm>
           <a:prstGeom prst="roundRect">
             <a:avLst>
-              <a:gd name="adj" fmla="val 5714"/>
+              <a:gd name="adj" fmla="val 6780"/>
             </a:avLst>
           </a:prstGeom>
           <a:solidFill>
@@ -32349,12 +32349,12 @@
         </p:nvSpPr>
         <p:spPr>
           <a:xfrm>
-            <a:off x="6507328" y="3383280"/>
-            <a:ext cx="457200" cy="457200"/>
+            <a:off x="6507328" y="3054096"/>
+            <a:ext cx="420624" cy="420624"/>
           </a:xfrm>
           <a:prstGeom prst="roundRect">
             <a:avLst>
-              <a:gd name="adj" fmla="val 20000"/>
+              <a:gd name="adj" fmla="val 21739"/>
             </a:avLst>
           </a:prstGeom>
           <a:solidFill>
@@ -32379,8 +32379,8 @@
         </p:blipFill>
         <p:spPr>
           <a:xfrm>
-            <a:off x="6617056" y="3493008"/>
-            <a:ext cx="237744" cy="237744"/>
+            <a:off x="6607912" y="3154680"/>
+            <a:ext cx="219456" cy="219456"/>
           </a:xfrm>
           <a:prstGeom prst="rect">
             <a:avLst/>
@@ -32395,8 +32395,8 @@
         </p:nvSpPr>
         <p:spPr>
           <a:xfrm>
-            <a:off x="7074256" y="3328416"/>
-            <a:ext cx="4449928" cy="310896"/>
+            <a:off x="7037680" y="2999232"/>
+            <a:ext cx="4486504" cy="274320"/>
           </a:xfrm>
           <a:prstGeom prst="rect">
             <a:avLst/>
@@ -32412,7 +32412,7 @@
               <a:buNone/>
             </a:pPr>
             <a:r>
-              <a:rPr lang="en-US" sz="1350" b="1" dirty="0">
+              <a:rPr lang="en-US" sz="1300" b="1" dirty="0">
                 <a:solidFill>
                   <a:srgbClr val="0F172A"/>
                 </a:solidFill>
@@ -32420,9 +32420,9 @@
                 <a:ea typeface="Calibri" pitchFamily="34" charset="-122"/>
                 <a:cs typeface="Calibri" pitchFamily="34" charset="-120"/>
               </a:rPr>
-              <a:t>Native function-calling + targeted ReAct</a:t>
-            </a:r>
-            <a:endParaRPr lang="en-US" sz="1350" dirty="0"/>
+              <a:t>Native function-calling</a:t>
+            </a:r>
+            <a:endParaRPr lang="en-US" sz="1300" dirty="0"/>
           </a:p>
         </p:txBody>
       </p:sp>
@@ -32434,8 +32434,8 @@
         </p:nvSpPr>
         <p:spPr>
           <a:xfrm>
-            <a:off x="7074256" y="3611880"/>
-            <a:ext cx="4449928" cy="237744"/>
+            <a:off x="7037680" y="3273552"/>
+            <a:ext cx="4486504" cy="219456"/>
           </a:xfrm>
           <a:prstGeom prst="rect">
             <a:avLst/>
@@ -32451,7 +32451,7 @@
               <a:buNone/>
             </a:pPr>
             <a:r>
-              <a:rPr lang="en-US" sz="1050" i="1" dirty="0">
+              <a:rPr lang="en-US" sz="1000" i="1" dirty="0">
                 <a:solidFill>
                   <a:srgbClr val="E11D48"/>
                 </a:solidFill>
@@ -32459,13 +32459,13 @@
                 <a:ea typeface="Calibri" pitchFamily="34" charset="-122"/>
                 <a:cs typeface="Calibri" pitchFamily="34" charset="-120"/>
               </a:rPr>
-              <a:t>Chosen over: </a:t>
+              <a:t>vs </a:t>
             </a:r>
             <a:pPr indent="0" marL="0">
               <a:buNone/>
             </a:pPr>
             <a:r>
-              <a:rPr lang="en-US" sz="1050" i="1" dirty="0">
+              <a:rPr lang="en-US" sz="1000" i="1" dirty="0">
                 <a:solidFill>
                   <a:srgbClr val="8A94A6"/>
                 </a:solidFill>
@@ -32473,9 +32473,9 @@
                 <a:ea typeface="Calibri" pitchFamily="34" charset="-122"/>
                 <a:cs typeface="Calibri" pitchFamily="34" charset="-120"/>
               </a:rPr>
-              <a:t>PlanReActPlanner everywhere</a:t>
-            </a:r>
-            <a:endParaRPr lang="en-US" sz="1050" dirty="0"/>
+              <a:t>ReAct everywhere</a:t>
+            </a:r>
+            <a:endParaRPr lang="en-US" sz="1000" dirty="0"/>
           </a:p>
         </p:txBody>
       </p:sp>
@@ -32487,8 +32487,8 @@
         </p:nvSpPr>
         <p:spPr>
           <a:xfrm>
-            <a:off x="6525616" y="3895344"/>
-            <a:ext cx="4980280" cy="512064"/>
+            <a:off x="6525616" y="3529584"/>
+            <a:ext cx="4980280" cy="384048"/>
           </a:xfrm>
           <a:prstGeom prst="rect">
             <a:avLst/>
@@ -32504,7 +32504,7 @@
               <a:buNone/>
             </a:pPr>
             <a:r>
-              <a:rPr lang="en-US" sz="1100" dirty="0">
+              <a:rPr lang="en-US" sz="1050" dirty="0">
                 <a:solidFill>
                   <a:srgbClr val="5B6577"/>
                 </a:solidFill>
@@ -32512,9 +32512,9 @@
                 <a:ea typeface="Calibri" pitchFamily="34" charset="-122"/>
                 <a:cs typeface="Calibri" pitchFamily="34" charset="-120"/>
               </a:rPr>
-              <a:t>Native tool-calling for production (reliable, fast); explicit ReAct only for the read-only advisor, where the visible plan adds value.</a:t>
-            </a:r>
-            <a:endParaRPr lang="en-US" sz="1100" dirty="0"/>
+              <a:t>No brittle text parsing; explicit ReAct only for the read-only advisor.</a:t>
+            </a:r>
+            <a:endParaRPr lang="en-US" sz="1050" dirty="0"/>
           </a:p>
         </p:txBody>
       </p:sp>
@@ -32526,12 +32526,12 @@
         </p:nvSpPr>
         <p:spPr>
           <a:xfrm>
-            <a:off x="502920" y="4626864"/>
-            <a:ext cx="5364328" cy="1280160"/>
+            <a:off x="502920" y="4078224"/>
+            <a:ext cx="5364328" cy="1078992"/>
           </a:xfrm>
           <a:prstGeom prst="roundRect">
             <a:avLst>
-              <a:gd name="adj" fmla="val 5714"/>
+              <a:gd name="adj" fmla="val 6780"/>
             </a:avLst>
           </a:prstGeom>
           <a:solidFill>
@@ -32560,12 +32560,12 @@
         </p:nvSpPr>
         <p:spPr>
           <a:xfrm>
-            <a:off x="685800" y="4828032"/>
-            <a:ext cx="457200" cy="457200"/>
+            <a:off x="685800" y="4261104"/>
+            <a:ext cx="420624" cy="420624"/>
           </a:xfrm>
           <a:prstGeom prst="roundRect">
             <a:avLst>
-              <a:gd name="adj" fmla="val 20000"/>
+              <a:gd name="adj" fmla="val 21739"/>
             </a:avLst>
           </a:prstGeom>
           <a:solidFill>
@@ -32576,7 +32576,7 @@
       </p:sp>
       <p:pic>
         <p:nvPicPr>
-          <p:cNvPr id="30" name="Image 4" descr="icons/cloud.png">    </p:cNvPr>
+          <p:cNvPr id="30" name="Image 4" descr="icons/check.png">    </p:cNvPr>
           <p:cNvPicPr>
             <a:picLocks noChangeAspect="1"/>
           </p:cNvPicPr>
@@ -32590,8 +32590,8 @@
         </p:blipFill>
         <p:spPr>
           <a:xfrm>
-            <a:off x="795528" y="4937760"/>
-            <a:ext cx="237744" cy="237744"/>
+            <a:off x="786384" y="4361688"/>
+            <a:ext cx="219456" cy="219456"/>
           </a:xfrm>
           <a:prstGeom prst="rect">
             <a:avLst/>
@@ -32606,8 +32606,8 @@
         </p:nvSpPr>
         <p:spPr>
           <a:xfrm>
-            <a:off x="1252728" y="4773168"/>
-            <a:ext cx="4449928" cy="310896"/>
+            <a:off x="1216152" y="4206240"/>
+            <a:ext cx="4486504" cy="274320"/>
           </a:xfrm>
           <a:prstGeom prst="rect">
             <a:avLst/>
@@ -32623,7 +32623,7 @@
               <a:buNone/>
             </a:pPr>
             <a:r>
-              <a:rPr lang="en-US" sz="1350" b="1" dirty="0">
+              <a:rPr lang="en-US" sz="1300" b="1" dirty="0">
                 <a:solidFill>
                   <a:srgbClr val="0F172A"/>
                 </a:solidFill>
@@ -32631,9 +32631,9 @@
                 <a:ea typeface="Calibri" pitchFamily="34" charset="-122"/>
                 <a:cs typeface="Calibri" pitchFamily="34" charset="-120"/>
               </a:rPr>
-              <a:t>Gemini 2.5 Flash on Vertex (one model)</a:t>
-            </a:r>
-            <a:endParaRPr lang="en-US" sz="1350" dirty="0"/>
+              <a:t>LLM-as-judge (RSI critic)</a:t>
+            </a:r>
+            <a:endParaRPr lang="en-US" sz="1300" dirty="0"/>
           </a:p>
         </p:txBody>
       </p:sp>
@@ -32645,8 +32645,8 @@
         </p:nvSpPr>
         <p:spPr>
           <a:xfrm>
-            <a:off x="1252728" y="5056632"/>
-            <a:ext cx="4449928" cy="237744"/>
+            <a:off x="1216152" y="4480560"/>
+            <a:ext cx="4486504" cy="219456"/>
           </a:xfrm>
           <a:prstGeom prst="rect">
             <a:avLst/>
@@ -32662,7 +32662,7 @@
               <a:buNone/>
             </a:pPr>
             <a:r>
-              <a:rPr lang="en-US" sz="1050" i="1" dirty="0">
+              <a:rPr lang="en-US" sz="1000" i="1" dirty="0">
                 <a:solidFill>
                   <a:srgbClr val="E11D48"/>
                 </a:solidFill>
@@ -32670,13 +32670,13 @@
                 <a:ea typeface="Calibri" pitchFamily="34" charset="-122"/>
                 <a:cs typeface="Calibri" pitchFamily="34" charset="-120"/>
               </a:rPr>
-              <a:t>Chosen over: </a:t>
+              <a:t>vs </a:t>
             </a:r>
             <a:pPr indent="0" marL="0">
               <a:buNone/>
             </a:pPr>
             <a:r>
-              <a:rPr lang="en-US" sz="1050" i="1" dirty="0">
+              <a:rPr lang="en-US" sz="1000" i="1" dirty="0">
                 <a:solidFill>
                   <a:srgbClr val="8A94A6"/>
                 </a:solidFill>
@@ -32684,9 +32684,9 @@
                 <a:ea typeface="Calibri" pitchFamily="34" charset="-122"/>
                 <a:cs typeface="Calibri" pitchFamily="34" charset="-120"/>
               </a:rPr>
-              <a:t>many models / self-hosted</a:t>
-            </a:r>
-            <a:endParaRPr lang="en-US" sz="1050" dirty="0"/>
+              <a:t>an ADK / ReAct critic</a:t>
+            </a:r>
+            <a:endParaRPr lang="en-US" sz="1000" dirty="0"/>
           </a:p>
         </p:txBody>
       </p:sp>
@@ -32698,8 +32698,8 @@
         </p:nvSpPr>
         <p:spPr>
           <a:xfrm>
-            <a:off x="704088" y="5340096"/>
-            <a:ext cx="4980280" cy="512064"/>
+            <a:off x="704088" y="4736592"/>
+            <a:ext cx="4980280" cy="384048"/>
           </a:xfrm>
           <a:prstGeom prst="rect">
             <a:avLst/>
@@ -32715,7 +32715,7 @@
               <a:buNone/>
             </a:pPr>
             <a:r>
-              <a:rPr lang="en-US" sz="1100" dirty="0">
+              <a:rPr lang="en-US" sz="1050" dirty="0">
                 <a:solidFill>
                   <a:srgbClr val="5B6577"/>
                 </a:solidFill>
@@ -32723,9 +32723,9 @@
                 <a:ea typeface="Calibri" pitchFamily="34" charset="-122"/>
                 <a:cs typeface="Calibri" pitchFamily="34" charset="-120"/>
               </a:rPr>
-              <a:t>One natively-multimodal model does reasoning, language AND vision — less ops, lower latency, Vertex security &amp; quota.</a:t>
-            </a:r>
-            <a:endParaRPr lang="en-US" sz="1100" dirty="0"/>
+              <a:t>Judging a failure is ONE structured call — no tool loop needed.</a:t>
+            </a:r>
+            <a:endParaRPr lang="en-US" sz="1050" dirty="0"/>
           </a:p>
         </p:txBody>
       </p:sp>
@@ -32737,12 +32737,12 @@
         </p:nvSpPr>
         <p:spPr>
           <a:xfrm>
-            <a:off x="6324448" y="4626864"/>
-            <a:ext cx="5364328" cy="1280160"/>
+            <a:off x="6324448" y="4078224"/>
+            <a:ext cx="5364328" cy="1078992"/>
           </a:xfrm>
           <a:prstGeom prst="roundRect">
             <a:avLst>
-              <a:gd name="adj" fmla="val 5714"/>
+              <a:gd name="adj" fmla="val 6780"/>
             </a:avLst>
           </a:prstGeom>
           <a:solidFill>
@@ -32771,12 +32771,12 @@
         </p:nvSpPr>
         <p:spPr>
           <a:xfrm>
-            <a:off x="6507328" y="4828032"/>
-            <a:ext cx="457200" cy="457200"/>
+            <a:off x="6507328" y="4261104"/>
+            <a:ext cx="420624" cy="420624"/>
           </a:xfrm>
           <a:prstGeom prst="roundRect">
             <a:avLst>
-              <a:gd name="adj" fmla="val 20000"/>
+              <a:gd name="adj" fmla="val 21739"/>
             </a:avLst>
           </a:prstGeom>
           <a:solidFill>
@@ -32787,7 +32787,7 @@
       </p:sp>
       <p:pic>
         <p:nvPicPr>
-          <p:cNvPr id="36" name="Image 5" descr="icons/sync.png">    </p:cNvPr>
+          <p:cNvPr id="36" name="Image 5" descr="icons/cloud.png">    </p:cNvPr>
           <p:cNvPicPr>
             <a:picLocks noChangeAspect="1"/>
           </p:cNvPicPr>
@@ -32801,8 +32801,8 @@
         </p:blipFill>
         <p:spPr>
           <a:xfrm>
-            <a:off x="6617056" y="4937760"/>
-            <a:ext cx="237744" cy="237744"/>
+            <a:off x="6607912" y="4361688"/>
+            <a:ext cx="219456" cy="219456"/>
           </a:xfrm>
           <a:prstGeom prst="rect">
             <a:avLst/>
@@ -32817,8 +32817,8 @@
         </p:nvSpPr>
         <p:spPr>
           <a:xfrm>
-            <a:off x="7074256" y="4773168"/>
-            <a:ext cx="4449928" cy="310896"/>
+            <a:off x="7037680" y="4206240"/>
+            <a:ext cx="4486504" cy="274320"/>
           </a:xfrm>
           <a:prstGeom prst="rect">
             <a:avLst/>
@@ -32834,7 +32834,7 @@
               <a:buNone/>
             </a:pPr>
             <a:r>
-              <a:rPr lang="en-US" sz="1350" b="1" dirty="0">
+              <a:rPr lang="en-US" sz="1300" b="1" dirty="0">
                 <a:solidFill>
                   <a:srgbClr val="0F172A"/>
                 </a:solidFill>
@@ -32842,9 +32842,9 @@
                 <a:ea typeface="Calibri" pitchFamily="34" charset="-122"/>
                 <a:cs typeface="Calibri" pitchFamily="34" charset="-120"/>
               </a:rPr>
-              <a:t>Graceful fallback + self-heal</a:t>
-            </a:r>
-            <a:endParaRPr lang="en-US" sz="1350" dirty="0"/>
+              <a:t>One Gemini model on Vertex</a:t>
+            </a:r>
+            <a:endParaRPr lang="en-US" sz="1300" dirty="0"/>
           </a:p>
         </p:txBody>
       </p:sp>
@@ -32856,8 +32856,8 @@
         </p:nvSpPr>
         <p:spPr>
           <a:xfrm>
-            <a:off x="7074256" y="5056632"/>
-            <a:ext cx="4449928" cy="237744"/>
+            <a:off x="7037680" y="4480560"/>
+            <a:ext cx="4486504" cy="219456"/>
           </a:xfrm>
           <a:prstGeom prst="rect">
             <a:avLst/>
@@ -32873,7 +32873,7 @@
               <a:buNone/>
             </a:pPr>
             <a:r>
-              <a:rPr lang="en-US" sz="1050" i="1" dirty="0">
+              <a:rPr lang="en-US" sz="1000" i="1" dirty="0">
                 <a:solidFill>
                   <a:srgbClr val="E11D48"/>
                 </a:solidFill>
@@ -32881,13 +32881,13 @@
                 <a:ea typeface="Calibri" pitchFamily="34" charset="-122"/>
                 <a:cs typeface="Calibri" pitchFamily="34" charset="-120"/>
               </a:rPr>
-              <a:t>Chosen over: </a:t>
+              <a:t>vs </a:t>
             </a:r>
             <a:pPr indent="0" marL="0">
               <a:buNone/>
             </a:pPr>
             <a:r>
-              <a:rPr lang="en-US" sz="1050" i="1" dirty="0">
+              <a:rPr lang="en-US" sz="1000" i="1" dirty="0">
                 <a:solidFill>
                   <a:srgbClr val="8A94A6"/>
                 </a:solidFill>
@@ -32895,9 +32895,9 @@
                 <a:ea typeface="Calibri" pitchFamily="34" charset="-122"/>
                 <a:cs typeface="Calibri" pitchFamily="34" charset="-120"/>
               </a:rPr>
-              <a:t>fail the request</a:t>
-            </a:r>
-            <a:endParaRPr lang="en-US" sz="1050" dirty="0"/>
+              <a:t>many models / self-host</a:t>
+            </a:r>
+            <a:endParaRPr lang="en-US" sz="1000" dirty="0"/>
           </a:p>
         </p:txBody>
       </p:sp>
@@ -32909,8 +32909,8 @@
         </p:nvSpPr>
         <p:spPr>
           <a:xfrm>
-            <a:off x="6525616" y="5340096"/>
-            <a:ext cx="4980280" cy="512064"/>
+            <a:off x="6525616" y="4736592"/>
+            <a:ext cx="4980280" cy="384048"/>
           </a:xfrm>
           <a:prstGeom prst="rect">
             <a:avLst/>
@@ -32926,7 +32926,7 @@
               <a:buNone/>
             </a:pPr>
             <a:r>
-              <a:rPr lang="en-US" sz="1100" dirty="0">
+              <a:rPr lang="en-US" sz="1050" dirty="0">
                 <a:solidFill>
                   <a:srgbClr val="5B6577"/>
                 </a:solidFill>
@@ -32934,15 +32934,381 @@
                 <a:ea typeface="Calibri" pitchFamily="34" charset="-122"/>
                 <a:cs typeface="Calibri" pitchFamily="34" charset="-120"/>
               </a:rPr>
-              <a:t>If the LLM/ADK path errors, a deterministic engine answers; the Guardian heals forward — the service degrades, it doesn't go down.</a:t>
-            </a:r>
-            <a:endParaRPr lang="en-US" sz="1100" dirty="0"/>
-          </a:p>
-        </p:txBody>
-      </p:sp>
-      <p:sp>
-        <p:nvSpPr>
-          <p:cNvPr id="40" name="Text 32"/>
+              <a:t>Reasoning + language + vision in one managed model — less ops.</a:t>
+            </a:r>
+            <a:endParaRPr lang="en-US" sz="1050" dirty="0"/>
+          </a:p>
+        </p:txBody>
+      </p:sp>
+      <p:sp>
+        <p:nvSpPr>
+          <p:cNvPr id="40" name="Shape 32"/>
+          <p:cNvSpPr/>
+          <p:nvPr/>
+        </p:nvSpPr>
+        <p:spPr>
+          <a:xfrm>
+            <a:off x="502920" y="5285232"/>
+            <a:ext cx="5364328" cy="1078992"/>
+          </a:xfrm>
+          <a:prstGeom prst="roundRect">
+            <a:avLst>
+              <a:gd name="adj" fmla="val 6780"/>
+            </a:avLst>
+          </a:prstGeom>
+          <a:solidFill>
+            <a:srgbClr val="FFFFFF"/>
+          </a:solidFill>
+          <a:ln w="12700">
+            <a:solidFill>
+              <a:srgbClr val="E6E8F0"/>
+            </a:solidFill>
+            <a:prstDash val="solid"/>
+          </a:ln>
+          <a:effectLst>
+            <a:outerShdw sx="100000" sy="100000" kx="0" ky="0" algn="bl" rotWithShape="0" blurRad="114300" dist="38100" dir="8100000">
+              <a:srgbClr val="0F172A">
+                <a:alpha val="16000"/>
+              </a:srgbClr>
+            </a:outerShdw>
+          </a:effectLst>
+        </p:spPr>
+      </p:sp>
+      <p:sp>
+        <p:nvSpPr>
+          <p:cNvPr id="41" name="Shape 33"/>
+          <p:cNvSpPr/>
+          <p:nvPr/>
+        </p:nvSpPr>
+        <p:spPr>
+          <a:xfrm>
+            <a:off x="685800" y="5468112"/>
+            <a:ext cx="420624" cy="420624"/>
+          </a:xfrm>
+          <a:prstGeom prst="roundRect">
+            <a:avLst>
+              <a:gd name="adj" fmla="val 21739"/>
+            </a:avLst>
+          </a:prstGeom>
+          <a:solidFill>
+            <a:srgbClr val="7C3AED"/>
+          </a:solidFill>
+          <a:ln/>
+        </p:spPr>
+      </p:sp>
+      <p:pic>
+        <p:nvPicPr>
+          <p:cNvPr id="42" name="Image 6" descr="icons/sync.png">    </p:cNvPr>
+          <p:cNvPicPr>
+            <a:picLocks noChangeAspect="1"/>
+          </p:cNvPicPr>
+          <p:nvPr/>
+        </p:nvPicPr>
+        <p:blipFill>
+          <a:blip r:embed="rId7"/>
+          <a:stretch>
+            <a:fillRect/>
+          </a:stretch>
+        </p:blipFill>
+        <p:spPr>
+          <a:xfrm>
+            <a:off x="786384" y="5568696"/>
+            <a:ext cx="219456" cy="219456"/>
+          </a:xfrm>
+          <a:prstGeom prst="rect">
+            <a:avLst/>
+          </a:prstGeom>
+        </p:spPr>
+      </p:pic>
+      <p:sp>
+        <p:nvSpPr>
+          <p:cNvPr id="43" name="Text 34"/>
+          <p:cNvSpPr/>
+          <p:nvPr/>
+        </p:nvSpPr>
+        <p:spPr>
+          <a:xfrm>
+            <a:off x="1216152" y="5413248"/>
+            <a:ext cx="4486504" cy="274320"/>
+          </a:xfrm>
+          <a:prstGeom prst="rect">
+            <a:avLst/>
+          </a:prstGeom>
+          <a:noFill/>
+          <a:ln/>
+        </p:spPr>
+        <p:txBody>
+          <a:bodyPr wrap="square" lIns="0" tIns="0" rIns="0" bIns="0" rtlCol="0" anchor="ctr"/>
+          <a:lstStyle/>
+          <a:p>
+            <a:pPr indent="0" marL="0">
+              <a:buNone/>
+            </a:pPr>
+            <a:r>
+              <a:rPr lang="en-US" sz="1300" b="1" dirty="0">
+                <a:solidFill>
+                  <a:srgbClr val="0F172A"/>
+                </a:solidFill>
+                <a:latin typeface="Calibri" pitchFamily="34" charset="0"/>
+                <a:ea typeface="Calibri" pitchFamily="34" charset="-122"/>
+                <a:cs typeface="Calibri" pitchFamily="34" charset="-120"/>
+              </a:rPr>
+              <a:t>Graceful fallback + self-heal</a:t>
+            </a:r>
+            <a:endParaRPr lang="en-US" sz="1300" dirty="0"/>
+          </a:p>
+        </p:txBody>
+      </p:sp>
+      <p:sp>
+        <p:nvSpPr>
+          <p:cNvPr id="44" name="Text 35"/>
+          <p:cNvSpPr/>
+          <p:nvPr/>
+        </p:nvSpPr>
+        <p:spPr>
+          <a:xfrm>
+            <a:off x="1216152" y="5687568"/>
+            <a:ext cx="4486504" cy="219456"/>
+          </a:xfrm>
+          <a:prstGeom prst="rect">
+            <a:avLst/>
+          </a:prstGeom>
+          <a:noFill/>
+          <a:ln/>
+        </p:spPr>
+        <p:txBody>
+          <a:bodyPr wrap="square" lIns="0" tIns="0" rIns="0" bIns="0" rtlCol="0" anchor="ctr"/>
+          <a:lstStyle/>
+          <a:p>
+            <a:pPr indent="0" marL="0">
+              <a:buNone/>
+            </a:pPr>
+            <a:r>
+              <a:rPr lang="en-US" sz="1000" i="1" dirty="0">
+                <a:solidFill>
+                  <a:srgbClr val="E11D48"/>
+                </a:solidFill>
+                <a:latin typeface="Calibri" pitchFamily="34" charset="0"/>
+                <a:ea typeface="Calibri" pitchFamily="34" charset="-122"/>
+                <a:cs typeface="Calibri" pitchFamily="34" charset="-120"/>
+              </a:rPr>
+              <a:t>vs </a:t>
+            </a:r>
+            <a:pPr indent="0" marL="0">
+              <a:buNone/>
+            </a:pPr>
+            <a:r>
+              <a:rPr lang="en-US" sz="1000" i="1" dirty="0">
+                <a:solidFill>
+                  <a:srgbClr val="8A94A6"/>
+                </a:solidFill>
+                <a:latin typeface="Calibri" pitchFamily="34" charset="0"/>
+                <a:ea typeface="Calibri" pitchFamily="34" charset="-122"/>
+                <a:cs typeface="Calibri" pitchFamily="34" charset="-120"/>
+              </a:rPr>
+              <a:t>fail the request</a:t>
+            </a:r>
+            <a:endParaRPr lang="en-US" sz="1000" dirty="0"/>
+          </a:p>
+        </p:txBody>
+      </p:sp>
+      <p:sp>
+        <p:nvSpPr>
+          <p:cNvPr id="45" name="Text 36"/>
+          <p:cNvSpPr/>
+          <p:nvPr/>
+        </p:nvSpPr>
+        <p:spPr>
+          <a:xfrm>
+            <a:off x="704088" y="5943600"/>
+            <a:ext cx="4980280" cy="384048"/>
+          </a:xfrm>
+          <a:prstGeom prst="rect">
+            <a:avLst/>
+          </a:prstGeom>
+          <a:noFill/>
+          <a:ln/>
+        </p:spPr>
+        <p:txBody>
+          <a:bodyPr wrap="square" lIns="0" tIns="0" rIns="0" bIns="0" rtlCol="0" anchor="t"/>
+          <a:lstStyle/>
+          <a:p>
+            <a:pPr indent="0" marL="0">
+              <a:buNone/>
+            </a:pPr>
+            <a:r>
+              <a:rPr lang="en-US" sz="1050" dirty="0">
+                <a:solidFill>
+                  <a:srgbClr val="5B6577"/>
+                </a:solidFill>
+                <a:latin typeface="Calibri" pitchFamily="34" charset="0"/>
+                <a:ea typeface="Calibri" pitchFamily="34" charset="-122"/>
+                <a:cs typeface="Calibri" pitchFamily="34" charset="-120"/>
+              </a:rPr>
+              <a:t>Degrade, don't go down — fallback engine + Guardian heal-forward.</a:t>
+            </a:r>
+            <a:endParaRPr lang="en-US" sz="1050" dirty="0"/>
+          </a:p>
+        </p:txBody>
+      </p:sp>
+      <p:sp>
+        <p:nvSpPr>
+          <p:cNvPr id="46" name="Shape 37"/>
+          <p:cNvSpPr/>
+          <p:nvPr/>
+        </p:nvSpPr>
+        <p:spPr>
+          <a:xfrm>
+            <a:off x="6324448" y="5285232"/>
+            <a:ext cx="5364328" cy="1078992"/>
+          </a:xfrm>
+          <a:prstGeom prst="roundRect">
+            <a:avLst>
+              <a:gd name="adj" fmla="val 6780"/>
+            </a:avLst>
+          </a:prstGeom>
+          <a:solidFill>
+            <a:srgbClr val="7C3AED"/>
+          </a:solidFill>
+          <a:ln/>
+          <a:effectLst>
+            <a:outerShdw sx="100000" sy="100000" kx="0" ky="0" algn="bl" rotWithShape="0" blurRad="114300" dist="38100" dir="8100000">
+              <a:srgbClr val="0F172A">
+                <a:alpha val="16000"/>
+              </a:srgbClr>
+            </a:outerShdw>
+          </a:effectLst>
+        </p:spPr>
+      </p:sp>
+      <p:sp>
+        <p:nvSpPr>
+          <p:cNvPr id="47" name="Shape 38"/>
+          <p:cNvSpPr/>
+          <p:nvPr/>
+        </p:nvSpPr>
+        <p:spPr>
+          <a:xfrm>
+            <a:off x="6507328" y="5468112"/>
+            <a:ext cx="420624" cy="420624"/>
+          </a:xfrm>
+          <a:prstGeom prst="roundRect">
+            <a:avLst>
+              <a:gd name="adj" fmla="val 21739"/>
+            </a:avLst>
+          </a:prstGeom>
+          <a:solidFill>
+            <a:srgbClr val="FFFFFF">
+              <a:alpha val="20000"/>
+            </a:srgbClr>
+          </a:solidFill>
+          <a:ln/>
+        </p:spPr>
+      </p:sp>
+      <p:pic>
+        <p:nvPicPr>
+          <p:cNvPr id="48" name="Image 7" descr="icons/bulb.png">    </p:cNvPr>
+          <p:cNvPicPr>
+            <a:picLocks noChangeAspect="1"/>
+          </p:cNvPicPr>
+          <p:nvPr/>
+        </p:nvPicPr>
+        <p:blipFill>
+          <a:blip r:embed="rId8"/>
+          <a:stretch>
+            <a:fillRect/>
+          </a:stretch>
+        </p:blipFill>
+        <p:spPr>
+          <a:xfrm>
+            <a:off x="6607912" y="5568696"/>
+            <a:ext cx="219456" cy="219456"/>
+          </a:xfrm>
+          <a:prstGeom prst="rect">
+            <a:avLst/>
+          </a:prstGeom>
+        </p:spPr>
+      </p:pic>
+      <p:sp>
+        <p:nvSpPr>
+          <p:cNvPr id="49" name="Text 39"/>
+          <p:cNvSpPr/>
+          <p:nvPr/>
+        </p:nvSpPr>
+        <p:spPr>
+          <a:xfrm>
+            <a:off x="7037680" y="5449824"/>
+            <a:ext cx="4486504" cy="274320"/>
+          </a:xfrm>
+          <a:prstGeom prst="rect">
+            <a:avLst/>
+          </a:prstGeom>
+          <a:noFill/>
+          <a:ln/>
+        </p:spPr>
+        <p:txBody>
+          <a:bodyPr wrap="square" lIns="0" tIns="0" rIns="0" bIns="0" rtlCol="0" anchor="ctr"/>
+          <a:lstStyle/>
+          <a:p>
+            <a:pPr indent="0" marL="0">
+              <a:buNone/>
+            </a:pPr>
+            <a:r>
+              <a:rPr lang="en-US" sz="1300" b="1" dirty="0">
+                <a:solidFill>
+                  <a:srgbClr val="FFFFFF"/>
+                </a:solidFill>
+                <a:latin typeface="Calibri" pitchFamily="34" charset="0"/>
+                <a:ea typeface="Calibri" pitchFamily="34" charset="-122"/>
+                <a:cs typeface="Calibri" pitchFamily="34" charset="-120"/>
+              </a:rPr>
+              <a:t>Full trade-off log</a:t>
+            </a:r>
+            <a:endParaRPr lang="en-US" sz="1300" dirty="0"/>
+          </a:p>
+        </p:txBody>
+      </p:sp>
+      <p:sp>
+        <p:nvSpPr>
+          <p:cNvPr id="50" name="Text 40"/>
+          <p:cNvSpPr/>
+          <p:nvPr/>
+        </p:nvSpPr>
+        <p:spPr>
+          <a:xfrm>
+            <a:off x="6525616" y="5852160"/>
+            <a:ext cx="4980280" cy="457200"/>
+          </a:xfrm>
+          <a:prstGeom prst="rect">
+            <a:avLst/>
+          </a:prstGeom>
+          <a:noFill/>
+          <a:ln/>
+        </p:spPr>
+        <p:txBody>
+          <a:bodyPr wrap="square" lIns="0" tIns="0" rIns="0" bIns="0" rtlCol="0" anchor="t"/>
+          <a:lstStyle/>
+          <a:p>
+            <a:pPr indent="0" marL="0">
+              <a:buNone/>
+            </a:pPr>
+            <a:r>
+              <a:rPr lang="en-US" sz="1050" dirty="0">
+                <a:solidFill>
+                  <a:srgbClr val="EDE7FB"/>
+                </a:solidFill>
+                <a:latin typeface="Calibri" pitchFamily="34" charset="0"/>
+                <a:ea typeface="Calibri" pitchFamily="34" charset="-122"/>
+                <a:cs typeface="Calibri" pitchFamily="34" charset="-120"/>
+              </a:rPr>
+              <a:t>TRADEOFFS.md — every decision: options considered → chosen → why / cost accepted.</a:t>
+            </a:r>
+            <a:endParaRPr lang="en-US" sz="1050" dirty="0"/>
+          </a:p>
+        </p:txBody>
+      </p:sp>
+      <p:sp>
+        <p:nvSpPr>
+          <p:cNvPr id="51" name="Text 41"/>
           <p:cNvSpPr/>
           <p:nvPr/>
         </p:nvSpPr>
@@ -32981,7 +33347,7 @@
       </p:sp>
       <p:sp>
         <p:nvSpPr>
-          <p:cNvPr id="41" name="Text 33"/>
+          <p:cNvPr id="52" name="Text 42"/>
           <p:cNvSpPr/>
           <p:nvPr/>
         </p:nvSpPr>

</xml_diff>